<commit_message>
fix(presentacion): corrige bug de CSS en slide final y aclara arquitectura de motores
El slide "Gracias" tenía display:flex sin condicionar a .active, por lo
que tapaba todas las demás slides. Además corrige el mensaje sobre
escalabilidad: agregar un producto nuevo requiere un motor de cálculo
propio, no modifica los existentes.
</commit_message>
<xml_diff>
--- a/presentation/calypso-knowledge-hub.pptx
+++ b/presentation/calypso-knowledge-hub.pptx
@@ -3840,7 +3840,7 @@
                 </a:solidFill>
                 <a:latin typeface="Calibri"/>
               </a:rPr>
-              <a:t>Productos escalables sin reescribir motor</a:t>
+              <a:t>Productos escalables agregando nuevos motores</a:t>
             </a:r>
           </a:p>
         </p:txBody>
@@ -4263,7 +4263,7 @@
                   <a:srgbClr val="6B7280"/>
                 </a:solidFill>
               </a:rPr>
-              <a:t>Arquitectura preparada para un back office real, sin reescribir motor ni interfaz.</a:t>
+              <a:t>Arquitectura preparada para un back office real y para sumar nuevos motores de producto sin tocar los existentes.</a:t>
             </a:r>
           </a:p>
         </p:txBody>
@@ -7695,7 +7695,7 @@
                 </a:solidFill>
                 <a:latin typeface="Calibri"/>
               </a:rPr>
-              <a:t>Soporta FX Spot, Forward FX y FX NDF desde el mismo motor, configurado por archivos JSON por producto.</a:t>
+              <a:t>Soporta FX Spot, Forward FX y FX NDF, configurados por archivos JSON por producto.</a:t>
             </a:r>
           </a:p>
         </p:txBody>
@@ -9354,7 +9354,7 @@
                   <a:srgbClr val="1F2430"/>
                 </a:solidFill>
               </a:rPr>
-              <a:t>Arquitectura por configuración</a:t>
+              <a:t>Arquitectura extensible por motores</a:t>
             </a:r>
           </a:p>
           <a:p>
@@ -9364,7 +9364,7 @@
                   <a:srgbClr val="6B7280"/>
                 </a:solidFill>
               </a:rPr>
-              <a:t>Agregar un producto financiero nuevo no requiere tocar el motor de cálculo.</a:t>
+              <a:t>Cada producto financiero tiene su propio motor de cálculo; agregar uno nuevo no modifica los existentes, solo se suma uno más.</a:t>
             </a:r>
           </a:p>
         </p:txBody>

</xml_diff>

<commit_message>
fix(presentacion): incrusta imagenes en base64 y agrega simulacion del generador XML
El HTML dependia de la carpeta img/ relativa, por lo que las imagenes no
cargaban al descargar solo el archivo; ahora van embebidas como base64.
Se reemplaza la captura unica del editor XML por una secuencia de 4 pasos
(cargar, estructura detectada, duplicar/editar bloques, exportar CDUF)
en ambos formatos (HTML y PPTX).
</commit_message>
<xml_diff>
--- a/presentation/calypso-knowledge-hub.pptx
+++ b/presentation/calypso-knowledge-hub.pptx
@@ -8220,7 +8220,7 @@
                 </a:solidFill>
                 <a:latin typeface="Calibri"/>
               </a:rPr>
-              <a:t>Editor de XML de trades (CDUF)</a:t>
+              <a:t>Simulación: generador de XML de trades (CDUF)</a:t>
             </a:r>
           </a:p>
         </p:txBody>
@@ -8233,8 +8233,8 @@
         </p:nvSpPr>
         <p:spPr>
           <a:xfrm>
-            <a:off x="548640" y="2011680"/>
-            <a:ext cx="5120640" cy="4114800"/>
+            <a:off x="548640" y="1783080"/>
+            <a:ext cx="10789920" cy="457200"/>
           </a:xfrm>
           <a:prstGeom prst="rect">
             <a:avLst/>
@@ -8247,42 +8247,109 @@
           </a:bodyPr>
           <a:lstStyle/>
           <a:p>
-            <a:pPr>
-              <a:spcAft>
-                <a:spcPts val="600"/>
-              </a:spcAft>
-            </a:pPr>
-            <a:r>
-              <a:rPr sz="1500">
+            <a:pPr algn="l"/>
+            <a:r>
+              <a:rPr sz="1400" b="0">
                 <a:solidFill>
                   <a:srgbClr val="6B7280"/>
                 </a:solidFill>
                 <a:latin typeface="Calibri"/>
               </a:rPr>
-              <a:t>Carga un XML de trade de Calypso y lo convierte en un formulario editable, con jerarquía visual de 3 niveles.</a:t>
-            </a:r>
-          </a:p>
-          <a:p>
-            <a:pPr>
-              <a:spcAft>
-                <a:spcPts val="600"/>
-              </a:spcAft>
-            </a:pPr>
-            <a:r>
-              <a:rPr sz="1500">
-                <a:solidFill>
-                  <a:srgbClr val="6B7280"/>
+              <a:t>Flujo completo de uso: cargar un XML real, editar/duplicar bloques y exportarlo de vuelta a CDUF.</a:t>
+            </a:r>
+          </a:p>
+        </p:txBody>
+      </p:sp>
+      <p:sp>
+        <p:nvSpPr>
+          <p:cNvPr id="8" name="Oval 7"/>
+          <p:cNvSpPr/>
+          <p:nvPr/>
+        </p:nvSpPr>
+        <p:spPr>
+          <a:xfrm>
+            <a:off x="548640" y="2331720"/>
+            <a:ext cx="256032" cy="256032"/>
+          </a:xfrm>
+          <a:prstGeom prst="ellipse">
+            <a:avLst/>
+          </a:prstGeom>
+          <a:solidFill>
+            <a:srgbClr val="E8622C"/>
+          </a:solidFill>
+          <a:ln>
+            <a:noFill/>
+          </a:ln>
+          <a:effectLst/>
+        </p:spPr>
+        <p:style>
+          <a:lnRef idx="1">
+            <a:schemeClr val="accent1"/>
+          </a:lnRef>
+          <a:fillRef idx="3">
+            <a:schemeClr val="accent1"/>
+          </a:fillRef>
+          <a:effectRef idx="2">
+            <a:schemeClr val="accent1"/>
+          </a:effectRef>
+          <a:fontRef idx="minor">
+            <a:schemeClr val="lt1"/>
+          </a:fontRef>
+        </p:style>
+        <p:txBody>
+          <a:bodyPr rtlCol="0" anchor="ctr"/>
+          <a:lstStyle/>
+          <a:p>
+            <a:pPr algn="ctr"/>
+            <a:r>
+              <a:rPr sz="1100" b="1">
+                <a:solidFill>
+                  <a:srgbClr val="FFFFFF"/>
+                </a:solidFill>
+              </a:rPr>
+              <a:t>1</a:t>
+            </a:r>
+          </a:p>
+        </p:txBody>
+      </p:sp>
+      <p:sp>
+        <p:nvSpPr>
+          <p:cNvPr id="9" name="TextBox 8"/>
+          <p:cNvSpPr txBox="1"/>
+          <p:nvPr/>
+        </p:nvSpPr>
+        <p:spPr>
+          <a:xfrm>
+            <a:off x="877824" y="2331720"/>
+            <a:ext cx="2377440" cy="274320"/>
+          </a:xfrm>
+          <a:prstGeom prst="rect">
+            <a:avLst/>
+          </a:prstGeom>
+          <a:noFill/>
+        </p:spPr>
+        <p:txBody>
+          <a:bodyPr wrap="square">
+            <a:spAutoFit/>
+          </a:bodyPr>
+          <a:lstStyle/>
+          <a:p>
+            <a:pPr algn="l"/>
+            <a:r>
+              <a:rPr sz="1100" b="1">
+                <a:solidFill>
+                  <a:srgbClr val="1F2430"/>
                 </a:solidFill>
                 <a:latin typeface="Calibri"/>
               </a:rPr>
-              <a:t>Campos y bloques repetibles (duplicar contrapartes, agregar valores), y exportación de vuelta a formato CDUF.</a:t>
+              <a:t>Cargar XML</a:t>
             </a:r>
           </a:p>
         </p:txBody>
       </p:sp>
       <p:pic>
         <p:nvPicPr>
-          <p:cNvPr id="8" name="Picture 7" descr="xml-editor.png"/>
+          <p:cNvPr id="10" name="Picture 9" descr="xml-1-upload.png"/>
           <p:cNvPicPr>
             <a:picLocks noChangeAspect="1"/>
           </p:cNvPicPr>
@@ -8296,8 +8363,341 @@
         </p:blipFill>
         <p:spPr>
           <a:xfrm>
-            <a:off x="5943600" y="1828800"/>
-            <a:ext cx="5669280" cy="3937000"/>
+            <a:off x="548640" y="2697480"/>
+            <a:ext cx="2651760" cy="1841500"/>
+          </a:xfrm>
+          <a:prstGeom prst="rect">
+            <a:avLst/>
+          </a:prstGeom>
+        </p:spPr>
+      </p:pic>
+      <p:sp>
+        <p:nvSpPr>
+          <p:cNvPr id="11" name="Oval 10"/>
+          <p:cNvSpPr/>
+          <p:nvPr/>
+        </p:nvSpPr>
+        <p:spPr>
+          <a:xfrm>
+            <a:off x="3337560" y="2331720"/>
+            <a:ext cx="256032" cy="256032"/>
+          </a:xfrm>
+          <a:prstGeom prst="ellipse">
+            <a:avLst/>
+          </a:prstGeom>
+          <a:solidFill>
+            <a:srgbClr val="E8622C"/>
+          </a:solidFill>
+          <a:ln>
+            <a:noFill/>
+          </a:ln>
+          <a:effectLst/>
+        </p:spPr>
+        <p:style>
+          <a:lnRef idx="1">
+            <a:schemeClr val="accent1"/>
+          </a:lnRef>
+          <a:fillRef idx="3">
+            <a:schemeClr val="accent1"/>
+          </a:fillRef>
+          <a:effectRef idx="2">
+            <a:schemeClr val="accent1"/>
+          </a:effectRef>
+          <a:fontRef idx="minor">
+            <a:schemeClr val="lt1"/>
+          </a:fontRef>
+        </p:style>
+        <p:txBody>
+          <a:bodyPr rtlCol="0" anchor="ctr"/>
+          <a:lstStyle/>
+          <a:p>
+            <a:pPr algn="ctr"/>
+            <a:r>
+              <a:rPr sz="1100" b="1">
+                <a:solidFill>
+                  <a:srgbClr val="FFFFFF"/>
+                </a:solidFill>
+              </a:rPr>
+              <a:t>2</a:t>
+            </a:r>
+          </a:p>
+        </p:txBody>
+      </p:sp>
+      <p:sp>
+        <p:nvSpPr>
+          <p:cNvPr id="12" name="TextBox 11"/>
+          <p:cNvSpPr txBox="1"/>
+          <p:nvPr/>
+        </p:nvSpPr>
+        <p:spPr>
+          <a:xfrm>
+            <a:off x="3666744" y="2331720"/>
+            <a:ext cx="2377440" cy="274320"/>
+          </a:xfrm>
+          <a:prstGeom prst="rect">
+            <a:avLst/>
+          </a:prstGeom>
+          <a:noFill/>
+        </p:spPr>
+        <p:txBody>
+          <a:bodyPr wrap="square">
+            <a:spAutoFit/>
+          </a:bodyPr>
+          <a:lstStyle/>
+          <a:p>
+            <a:pPr algn="l"/>
+            <a:r>
+              <a:rPr sz="1100" b="1">
+                <a:solidFill>
+                  <a:srgbClr val="1F2430"/>
+                </a:solidFill>
+                <a:latin typeface="Calibri"/>
+              </a:rPr>
+              <a:t>Estructura detectada</a:t>
+            </a:r>
+          </a:p>
+        </p:txBody>
+      </p:sp>
+      <p:pic>
+        <p:nvPicPr>
+          <p:cNvPr id="13" name="Picture 12" descr="xml-2-loaded.png"/>
+          <p:cNvPicPr>
+            <a:picLocks noChangeAspect="1"/>
+          </p:cNvPicPr>
+          <p:nvPr/>
+        </p:nvPicPr>
+        <p:blipFill>
+          <a:blip r:embed="rId3"/>
+          <a:stretch>
+            <a:fillRect/>
+          </a:stretch>
+        </p:blipFill>
+        <p:spPr>
+          <a:xfrm>
+            <a:off x="3337560" y="2697480"/>
+            <a:ext cx="2651760" cy="1841500"/>
+          </a:xfrm>
+          <a:prstGeom prst="rect">
+            <a:avLst/>
+          </a:prstGeom>
+        </p:spPr>
+      </p:pic>
+      <p:sp>
+        <p:nvSpPr>
+          <p:cNvPr id="14" name="Oval 13"/>
+          <p:cNvSpPr/>
+          <p:nvPr/>
+        </p:nvSpPr>
+        <p:spPr>
+          <a:xfrm>
+            <a:off x="6126479" y="2331720"/>
+            <a:ext cx="256032" cy="256032"/>
+          </a:xfrm>
+          <a:prstGeom prst="ellipse">
+            <a:avLst/>
+          </a:prstGeom>
+          <a:solidFill>
+            <a:srgbClr val="E8622C"/>
+          </a:solidFill>
+          <a:ln>
+            <a:noFill/>
+          </a:ln>
+          <a:effectLst/>
+        </p:spPr>
+        <p:style>
+          <a:lnRef idx="1">
+            <a:schemeClr val="accent1"/>
+          </a:lnRef>
+          <a:fillRef idx="3">
+            <a:schemeClr val="accent1"/>
+          </a:fillRef>
+          <a:effectRef idx="2">
+            <a:schemeClr val="accent1"/>
+          </a:effectRef>
+          <a:fontRef idx="minor">
+            <a:schemeClr val="lt1"/>
+          </a:fontRef>
+        </p:style>
+        <p:txBody>
+          <a:bodyPr rtlCol="0" anchor="ctr"/>
+          <a:lstStyle/>
+          <a:p>
+            <a:pPr algn="ctr"/>
+            <a:r>
+              <a:rPr sz="1100" b="1">
+                <a:solidFill>
+                  <a:srgbClr val="FFFFFF"/>
+                </a:solidFill>
+              </a:rPr>
+              <a:t>3</a:t>
+            </a:r>
+          </a:p>
+        </p:txBody>
+      </p:sp>
+      <p:sp>
+        <p:nvSpPr>
+          <p:cNvPr id="15" name="TextBox 14"/>
+          <p:cNvSpPr txBox="1"/>
+          <p:nvPr/>
+        </p:nvSpPr>
+        <p:spPr>
+          <a:xfrm>
+            <a:off x="6455664" y="2331720"/>
+            <a:ext cx="2377440" cy="274320"/>
+          </a:xfrm>
+          <a:prstGeom prst="rect">
+            <a:avLst/>
+          </a:prstGeom>
+          <a:noFill/>
+        </p:spPr>
+        <p:txBody>
+          <a:bodyPr wrap="square">
+            <a:spAutoFit/>
+          </a:bodyPr>
+          <a:lstStyle/>
+          <a:p>
+            <a:pPr algn="l"/>
+            <a:r>
+              <a:rPr sz="1100" b="1">
+                <a:solidFill>
+                  <a:srgbClr val="1F2430"/>
+                </a:solidFill>
+                <a:latin typeface="Calibri"/>
+              </a:rPr>
+              <a:t>Duplicar / editar bloques</a:t>
+            </a:r>
+          </a:p>
+        </p:txBody>
+      </p:sp>
+      <p:pic>
+        <p:nvPicPr>
+          <p:cNvPr id="16" name="Picture 15" descr="xml-3-editado.png"/>
+          <p:cNvPicPr>
+            <a:picLocks noChangeAspect="1"/>
+          </p:cNvPicPr>
+          <p:nvPr/>
+        </p:nvPicPr>
+        <p:blipFill>
+          <a:blip r:embed="rId4"/>
+          <a:stretch>
+            <a:fillRect/>
+          </a:stretch>
+        </p:blipFill>
+        <p:spPr>
+          <a:xfrm>
+            <a:off x="6126479" y="2697480"/>
+            <a:ext cx="2651760" cy="1841500"/>
+          </a:xfrm>
+          <a:prstGeom prst="rect">
+            <a:avLst/>
+          </a:prstGeom>
+        </p:spPr>
+      </p:pic>
+      <p:sp>
+        <p:nvSpPr>
+          <p:cNvPr id="17" name="Oval 16"/>
+          <p:cNvSpPr/>
+          <p:nvPr/>
+        </p:nvSpPr>
+        <p:spPr>
+          <a:xfrm>
+            <a:off x="8915400" y="2331720"/>
+            <a:ext cx="256032" cy="256032"/>
+          </a:xfrm>
+          <a:prstGeom prst="ellipse">
+            <a:avLst/>
+          </a:prstGeom>
+          <a:solidFill>
+            <a:srgbClr val="E8622C"/>
+          </a:solidFill>
+          <a:ln>
+            <a:noFill/>
+          </a:ln>
+          <a:effectLst/>
+        </p:spPr>
+        <p:style>
+          <a:lnRef idx="1">
+            <a:schemeClr val="accent1"/>
+          </a:lnRef>
+          <a:fillRef idx="3">
+            <a:schemeClr val="accent1"/>
+          </a:fillRef>
+          <a:effectRef idx="2">
+            <a:schemeClr val="accent1"/>
+          </a:effectRef>
+          <a:fontRef idx="minor">
+            <a:schemeClr val="lt1"/>
+          </a:fontRef>
+        </p:style>
+        <p:txBody>
+          <a:bodyPr rtlCol="0" anchor="ctr"/>
+          <a:lstStyle/>
+          <a:p>
+            <a:pPr algn="ctr"/>
+            <a:r>
+              <a:rPr sz="1100" b="1">
+                <a:solidFill>
+                  <a:srgbClr val="FFFFFF"/>
+                </a:solidFill>
+              </a:rPr>
+              <a:t>4</a:t>
+            </a:r>
+          </a:p>
+        </p:txBody>
+      </p:sp>
+      <p:sp>
+        <p:nvSpPr>
+          <p:cNvPr id="18" name="TextBox 17"/>
+          <p:cNvSpPr txBox="1"/>
+          <p:nvPr/>
+        </p:nvSpPr>
+        <p:spPr>
+          <a:xfrm>
+            <a:off x="9244584" y="2331720"/>
+            <a:ext cx="2377440" cy="274320"/>
+          </a:xfrm>
+          <a:prstGeom prst="rect">
+            <a:avLst/>
+          </a:prstGeom>
+          <a:noFill/>
+        </p:spPr>
+        <p:txBody>
+          <a:bodyPr wrap="square">
+            <a:spAutoFit/>
+          </a:bodyPr>
+          <a:lstStyle/>
+          <a:p>
+            <a:pPr algn="l"/>
+            <a:r>
+              <a:rPr sz="1100" b="1">
+                <a:solidFill>
+                  <a:srgbClr val="1F2430"/>
+                </a:solidFill>
+                <a:latin typeface="Calibri"/>
+              </a:rPr>
+              <a:t>Guardar y exportar CDUF</a:t>
+            </a:r>
+          </a:p>
+        </p:txBody>
+      </p:sp>
+      <p:pic>
+        <p:nvPicPr>
+          <p:cNvPr id="19" name="Picture 18" descr="xml-4-registro.png"/>
+          <p:cNvPicPr>
+            <a:picLocks noChangeAspect="1"/>
+          </p:cNvPicPr>
+          <p:nvPr/>
+        </p:nvPicPr>
+        <p:blipFill>
+          <a:blip r:embed="rId5"/>
+          <a:stretch>
+            <a:fillRect/>
+          </a:stretch>
+        </p:blipFill>
+        <p:spPr>
+          <a:xfrm>
+            <a:off x="8915400" y="2697480"/>
+            <a:ext cx="2651760" cy="1841500"/>
           </a:xfrm>
           <a:prstGeom prst="rect">
             <a:avLst/>

</xml_diff>